<commit_message>
vault backup: 2026-04-21 15:17:00
</commit_message>
<xml_diff>
--- a/50_Resources/Physics/InFlightFission/InFlightFission_Intro.pptx
+++ b/50_Resources/Physics/InFlightFission/InFlightFission_Intro.pptx
@@ -2213,7 +2213,7 @@
           <a:ln/>
         </p:spPr>
         <p:txBody>
-          <a:bodyPr wrap="square" lIns="0" tIns="0" rIns="0" bIns="0" rtlCol="0" anchor="ctr"/>
+          <a:bodyPr wrap="square" lIns="0" tIns="0" rIns="0" bIns="0" rtlCol="0" anchor="t"/>
           <a:lstStyle/>
           <a:p>
             <a:pPr indent="0" marL="0">
@@ -2390,7 +2390,41 @@
                 <a:ea typeface="Calibri" pitchFamily="34" charset="-122"/>
                 <a:cs typeface="Calibri" pitchFamily="34" charset="-120"/>
               </a:rPr>
-              <a:t>in-flight fission of 238U</a:t>
+              <a:t>in-flight fission of </a:t>
+            </a:r>
+            <a:pPr indent="0" marL="0">
+              <a:spcAft>
+                <a:spcPts val="800"/>
+              </a:spcAft>
+              <a:buNone/>
+            </a:pPr>
+            <a:r>
+              <a:rPr lang="en-US" sz="1500" b="1" baseline="30000" dirty="0">
+                <a:solidFill>
+                  <a:srgbClr val="1E293B"/>
+                </a:solidFill>
+                <a:latin typeface="Calibri" pitchFamily="34" charset="0"/>
+                <a:ea typeface="Calibri" pitchFamily="34" charset="-122"/>
+                <a:cs typeface="Calibri" pitchFamily="34" charset="-120"/>
+              </a:rPr>
+              <a:t>238</a:t>
+            </a:r>
+            <a:pPr indent="0" marL="0">
+              <a:spcAft>
+                <a:spcPts val="800"/>
+              </a:spcAft>
+              <a:buNone/>
+            </a:pPr>
+            <a:r>
+              <a:rPr lang="en-US" sz="1500" b="1" dirty="0">
+                <a:solidFill>
+                  <a:srgbClr val="1E293B"/>
+                </a:solidFill>
+                <a:latin typeface="Calibri" pitchFamily="34" charset="0"/>
+                <a:ea typeface="Calibri" pitchFamily="34" charset="-122"/>
+                <a:cs typeface="Calibri" pitchFamily="34" charset="-120"/>
+              </a:rPr>
+              <a:t>U</a:t>
             </a:r>
             <a:pPr indent="0" marL="0">
               <a:spcAft>
@@ -3425,9 +3459,26 @@
           <a:ln/>
         </p:spPr>
         <p:txBody>
-          <a:bodyPr wrap="square" lIns="0" tIns="0" rIns="0" bIns="0" rtlCol="0" anchor="ctr"/>
-          <a:lstStyle/>
-          <a:p>
+          <a:bodyPr wrap="square" lIns="0" tIns="0" rIns="0" bIns="0" rtlCol="0" anchor="t"/>
+          <a:lstStyle/>
+          <a:p>
+            <a:pPr indent="0" marL="0">
+              <a:buNone/>
+            </a:pPr>
+            <a:pPr indent="0" marL="0">
+              <a:buNone/>
+            </a:pPr>
+            <a:r>
+              <a:rPr lang="en-US" sz="1100" baseline="30000" dirty="0">
+                <a:solidFill>
+                  <a:srgbClr val="1E293B"/>
+                </a:solidFill>
+                <a:latin typeface="Calibri" pitchFamily="34" charset="0"/>
+                <a:ea typeface="Calibri" pitchFamily="34" charset="-122"/>
+                <a:cs typeface="Calibri" pitchFamily="34" charset="-120"/>
+              </a:rPr>
+              <a:t>238</a:t>
+            </a:r>
             <a:pPr indent="0" marL="0">
               <a:buNone/>
             </a:pPr>
@@ -3440,7 +3491,7 @@
                 <a:ea typeface="Calibri" pitchFamily="34" charset="-122"/>
                 <a:cs typeface="Calibri" pitchFamily="34" charset="-120"/>
               </a:rPr>
-              <a:t>238U accelerated to 345 MeV/u (RIBF) or 400–1000 MeV/u (GSI).</a:t>
+              <a:t>U accelerated to 345 MeV/u (RIBF) or 400–1000 MeV/u (GSI).</a:t>
             </a:r>
             <a:endParaRPr lang="en-US" sz="1100" dirty="0"/>
           </a:p>
@@ -3623,7 +3674,7 @@
           <a:ln/>
         </p:spPr>
         <p:txBody>
-          <a:bodyPr wrap="square" lIns="0" tIns="0" rIns="0" bIns="0" rtlCol="0" anchor="ctr"/>
+          <a:bodyPr wrap="square" lIns="0" tIns="0" rIns="0" bIns="0" rtlCol="0" anchor="t"/>
           <a:lstStyle/>
           <a:p>
             <a:pPr indent="0" marL="0">
@@ -3821,7 +3872,7 @@
           <a:ln/>
         </p:spPr>
         <p:txBody>
-          <a:bodyPr wrap="square" lIns="0" tIns="0" rIns="0" bIns="0" rtlCol="0" anchor="ctr"/>
+          <a:bodyPr wrap="square" lIns="0" tIns="0" rIns="0" bIns="0" rtlCol="0" anchor="t"/>
           <a:lstStyle/>
           <a:p>
             <a:pPr indent="0" marL="0">
@@ -4019,7 +4070,7 @@
           <a:ln/>
         </p:spPr>
         <p:txBody>
-          <a:bodyPr wrap="square" lIns="0" tIns="0" rIns="0" bIns="0" rtlCol="0" anchor="ctr"/>
+          <a:bodyPr wrap="square" lIns="0" tIns="0" rIns="0" bIns="0" rtlCol="0" anchor="t"/>
           <a:lstStyle/>
           <a:p>
             <a:pPr indent="0" marL="0">
@@ -5369,6 +5420,20 @@
               <a:buNone/>
             </a:pPr>
             <a:r>
+              <a:rPr lang="en-US" sz="1200" baseline="30000" dirty="0">
+                <a:solidFill>
+                  <a:srgbClr val="1E293B"/>
+                </a:solidFill>
+                <a:latin typeface="Calibri" pitchFamily="34" charset="0"/>
+                <a:ea typeface="Calibri" pitchFamily="34" charset="-122"/>
+                <a:cs typeface="Calibri" pitchFamily="34" charset="-120"/>
+              </a:rPr>
+              <a:t>238</a:t>
+            </a:r>
+            <a:pPr indent="0" marL="0">
+              <a:buNone/>
+            </a:pPr>
+            <a:r>
               <a:rPr lang="en-US" sz="1200" dirty="0">
                 <a:solidFill>
                   <a:srgbClr val="1E293B"/>
@@ -5377,7 +5442,7 @@
                 <a:ea typeface="Calibri" pitchFamily="34" charset="-122"/>
                 <a:cs typeface="Calibri" pitchFamily="34" charset="-120"/>
               </a:rPr>
-              <a:t>238U → Be</a:t>
+              <a:t>U → Be</a:t>
             </a:r>
             <a:endParaRPr lang="en-US" sz="1200" dirty="0"/>
           </a:p>
@@ -5882,6 +5947,20 @@
               <a:buNone/>
             </a:pPr>
             <a:r>
+              <a:rPr lang="en-US" sz="1200" baseline="30000" dirty="0">
+                <a:solidFill>
+                  <a:srgbClr val="1E293B"/>
+                </a:solidFill>
+                <a:latin typeface="Calibri" pitchFamily="34" charset="0"/>
+                <a:ea typeface="Calibri" pitchFamily="34" charset="-122"/>
+                <a:cs typeface="Calibri" pitchFamily="34" charset="-120"/>
+              </a:rPr>
+              <a:t>238</a:t>
+            </a:r>
+            <a:pPr indent="0" marL="0">
+              <a:buNone/>
+            </a:pPr>
+            <a:r>
               <a:rPr lang="en-US" sz="1200" dirty="0">
                 <a:solidFill>
                   <a:srgbClr val="1E293B"/>
@@ -5890,7 +5969,7 @@
                 <a:ea typeface="Calibri" pitchFamily="34" charset="-122"/>
                 <a:cs typeface="Calibri" pitchFamily="34" charset="-120"/>
               </a:rPr>
-              <a:t>238U → Be</a:t>
+              <a:t>U → Be</a:t>
             </a:r>
             <a:endParaRPr lang="en-US" sz="1200" dirty="0"/>
           </a:p>
@@ -7208,7 +7287,35 @@
                 <a:ea typeface="Calibri" pitchFamily="34" charset="-122"/>
                 <a:cs typeface="Calibri" pitchFamily="34" charset="-120"/>
               </a:rPr>
-              <a:t>First observation — produced by in-flight fission of 345 MeV/u 238U on Be, in a commissioning run of ≈ 1 day at 0.007 pnA average beam current.</a:t>
+              <a:t>First observation — produced by in-flight fission of 345 MeV/u </a:t>
+            </a:r>
+            <a:pPr indent="0" marL="0">
+              <a:buNone/>
+            </a:pPr>
+            <a:r>
+              <a:rPr lang="en-US" sz="1200" baseline="30000" dirty="0">
+                <a:solidFill>
+                  <a:srgbClr val="1E293B"/>
+                </a:solidFill>
+                <a:latin typeface="Calibri" pitchFamily="34" charset="0"/>
+                <a:ea typeface="Calibri" pitchFamily="34" charset="-122"/>
+                <a:cs typeface="Calibri" pitchFamily="34" charset="-120"/>
+              </a:rPr>
+              <a:t>238</a:t>
+            </a:r>
+            <a:pPr indent="0" marL="0">
+              <a:buNone/>
+            </a:pPr>
+            <a:r>
+              <a:rPr lang="en-US" sz="1200" dirty="0">
+                <a:solidFill>
+                  <a:srgbClr val="1E293B"/>
+                </a:solidFill>
+                <a:latin typeface="Calibri" pitchFamily="34" charset="0"/>
+                <a:ea typeface="Calibri" pitchFamily="34" charset="-122"/>
+                <a:cs typeface="Calibri" pitchFamily="34" charset="-120"/>
+              </a:rPr>
+              <a:t>U on Be, in a commissioning run of ≈ 1 day at 0.007 pnA average beam current.</a:t>
             </a:r>
             <a:endParaRPr lang="en-US" sz="1200" dirty="0"/>
           </a:p>
@@ -7673,8 +7780,8 @@
         </p:nvSpPr>
         <p:spPr>
           <a:xfrm>
-            <a:off x="457200" y="4937760"/>
-            <a:ext cx="11277295" cy="1143000"/>
+            <a:off x="457200" y="4846320"/>
+            <a:ext cx="11277295" cy="1097280"/>
           </a:xfrm>
           <a:prstGeom prst="rect">
             <a:avLst/>
@@ -7698,8 +7805,8 @@
         </p:nvSpPr>
         <p:spPr>
           <a:xfrm>
-            <a:off x="731520" y="5029200"/>
-            <a:ext cx="2743200" cy="292608"/>
+            <a:off x="731520" y="4919472"/>
+            <a:ext cx="2743200" cy="274320"/>
           </a:xfrm>
           <a:prstGeom prst="rect">
             <a:avLst/>
@@ -7737,17 +7844,17 @@
         </p:nvSpPr>
         <p:spPr>
           <a:xfrm>
-            <a:off x="731520" y="5349240"/>
-            <a:ext cx="10728655" cy="685800"/>
-          </a:xfrm>
-          <a:prstGeom prst="rect">
-            <a:avLst/>
-          </a:prstGeom>
-          <a:noFill/>
-          <a:ln/>
-        </p:spPr>
-        <p:txBody>
-          <a:bodyPr wrap="square" lIns="0" tIns="0" rIns="0" bIns="0" rtlCol="0" anchor="ctr"/>
+            <a:off x="731520" y="5230368"/>
+            <a:ext cx="10728655" cy="658368"/>
+          </a:xfrm>
+          <a:prstGeom prst="rect">
+            <a:avLst/>
+          </a:prstGeom>
+          <a:noFill/>
+          <a:ln/>
+        </p:spPr>
+        <p:txBody>
+          <a:bodyPr wrap="square" lIns="0" tIns="0" rIns="0" bIns="0" rtlCol="0" anchor="t"/>
           <a:lstStyle/>
           <a:p>
             <a:pPr indent="0" marL="0">
@@ -7762,7 +7869,35 @@
                 <a:ea typeface="Calibri" pitchFamily="34" charset="-122"/>
                 <a:cs typeface="Calibri" pitchFamily="34" charset="-120"/>
               </a:rPr>
-              <a:t>Even in its commissioning phase, BigRIPS established in-flight fission of 238U as the dominant production route for mid-mass neutron-rich exotica — a role it has only expanded since.</a:t>
+              <a:t>Even in its commissioning phase, BigRIPS established in-flight fission of </a:t>
+            </a:r>
+            <a:pPr indent="0" marL="0">
+              <a:buNone/>
+            </a:pPr>
+            <a:r>
+              <a:rPr lang="en-US" sz="1400" baseline="30000" dirty="0">
+                <a:solidFill>
+                  <a:srgbClr val="F8FAFC"/>
+                </a:solidFill>
+                <a:latin typeface="Calibri" pitchFamily="34" charset="0"/>
+                <a:ea typeface="Calibri" pitchFamily="34" charset="-122"/>
+                <a:cs typeface="Calibri" pitchFamily="34" charset="-120"/>
+              </a:rPr>
+              <a:t>238</a:t>
+            </a:r>
+            <a:pPr indent="0" marL="0">
+              <a:buNone/>
+            </a:pPr>
+            <a:r>
+              <a:rPr lang="en-US" sz="1400" dirty="0">
+                <a:solidFill>
+                  <a:srgbClr val="F8FAFC"/>
+                </a:solidFill>
+                <a:latin typeface="Calibri" pitchFamily="34" charset="0"/>
+                <a:ea typeface="Calibri" pitchFamily="34" charset="-122"/>
+                <a:cs typeface="Calibri" pitchFamily="34" charset="-120"/>
+              </a:rPr>
+              <a:t>U as the dominant production route for mid-mass neutron-rich exotica — a role it has only expanded since.</a:t>
             </a:r>
             <a:endParaRPr lang="en-US" sz="1400" dirty="0"/>
           </a:p>
@@ -8037,7 +8172,35 @@
                 <a:ea typeface="Cambria" pitchFamily="34" charset="-122"/>
                 <a:cs typeface="Cambria" pitchFamily="34" charset="-120"/>
               </a:rPr>
-              <a:t>FRS at GSI: Fragmentation + Fission of 1 GeV/u 238U</a:t>
+              <a:t>FRS at GSI: Fragmentation + Fission of 1 GeV/u </a:t>
+            </a:r>
+            <a:pPr indent="0" marL="0">
+              <a:buNone/>
+            </a:pPr>
+            <a:r>
+              <a:rPr lang="en-US" sz="2800" b="1" baseline="30000" dirty="0">
+                <a:solidFill>
+                  <a:srgbClr val="1E293B"/>
+                </a:solidFill>
+                <a:latin typeface="Cambria" pitchFamily="34" charset="0"/>
+                <a:ea typeface="Cambria" pitchFamily="34" charset="-122"/>
+                <a:cs typeface="Cambria" pitchFamily="34" charset="-120"/>
+              </a:rPr>
+              <a:t>238</a:t>
+            </a:r>
+            <a:pPr indent="0" marL="0">
+              <a:buNone/>
+            </a:pPr>
+            <a:r>
+              <a:rPr lang="en-US" sz="2800" b="1" dirty="0">
+                <a:solidFill>
+                  <a:srgbClr val="1E293B"/>
+                </a:solidFill>
+                <a:latin typeface="Cambria" pitchFamily="34" charset="0"/>
+                <a:ea typeface="Cambria" pitchFamily="34" charset="-122"/>
+                <a:cs typeface="Cambria" pitchFamily="34" charset="-120"/>
+              </a:rPr>
+              <a:t>U</a:t>
             </a:r>
             <a:endParaRPr lang="en-US" sz="2800" dirty="0"/>
           </a:p>
@@ -8250,7 +8413,35 @@
                 <a:ea typeface="Calibri" pitchFamily="34" charset="-122"/>
                 <a:cs typeface="Calibri" pitchFamily="34" charset="-120"/>
               </a:rPr>
-              <a:t>discovered in a single dedicated FRS campaign, spanning Nd (Z = 60) through Pt (Z = 78), with 238U at 1 GeV/u on a Be production target.</a:t>
+              <a:t>discovered in a single dedicated FRS campaign, spanning Nd (Z = 60) through Pt (Z = 78), with </a:t>
+            </a:r>
+            <a:pPr indent="0" marL="0">
+              <a:buNone/>
+            </a:pPr>
+            <a:r>
+              <a:rPr lang="en-US" sz="1200" baseline="30000" dirty="0">
+                <a:solidFill>
+                  <a:srgbClr val="1E293B"/>
+                </a:solidFill>
+                <a:latin typeface="Calibri" pitchFamily="34" charset="0"/>
+                <a:ea typeface="Calibri" pitchFamily="34" charset="-122"/>
+                <a:cs typeface="Calibri" pitchFamily="34" charset="-120"/>
+              </a:rPr>
+              <a:t>238</a:t>
+            </a:r>
+            <a:pPr indent="0" marL="0">
+              <a:buNone/>
+            </a:pPr>
+            <a:r>
+              <a:rPr lang="en-US" sz="1200" dirty="0">
+                <a:solidFill>
+                  <a:srgbClr val="1E293B"/>
+                </a:solidFill>
+                <a:latin typeface="Calibri" pitchFamily="34" charset="0"/>
+                <a:ea typeface="Calibri" pitchFamily="34" charset="-122"/>
+                <a:cs typeface="Calibri" pitchFamily="34" charset="-120"/>
+              </a:rPr>
+              <a:t>U at 1 GeV/u on a Be production target.</a:t>
             </a:r>
             <a:endParaRPr lang="en-US" sz="1200" dirty="0"/>
           </a:p>
@@ -9053,7 +9244,35 @@
                 <a:ea typeface="Calibri" pitchFamily="34" charset="-122"/>
                 <a:cs typeface="Calibri" pitchFamily="34" charset="-120"/>
               </a:rPr>
-              <a:t>produced by 345 MeV/u 238U + Be in-flight fission, separated and identified by BigRIPS:</a:t>
+              <a:t>produced by 345 MeV/u </a:t>
+            </a:r>
+            <a:pPr indent="0" marL="0">
+              <a:buNone/>
+            </a:pPr>
+            <a:r>
+              <a:rPr lang="en-US" sz="1200" baseline="30000" dirty="0">
+                <a:solidFill>
+                  <a:srgbClr val="1E293B"/>
+                </a:solidFill>
+                <a:latin typeface="Calibri" pitchFamily="34" charset="0"/>
+                <a:ea typeface="Calibri" pitchFamily="34" charset="-122"/>
+                <a:cs typeface="Calibri" pitchFamily="34" charset="-120"/>
+              </a:rPr>
+              <a:t>238</a:t>
+            </a:r>
+            <a:pPr indent="0" marL="0">
+              <a:buNone/>
+            </a:pPr>
+            <a:r>
+              <a:rPr lang="en-US" sz="1200" dirty="0">
+                <a:solidFill>
+                  <a:srgbClr val="1E293B"/>
+                </a:solidFill>
+                <a:latin typeface="Calibri" pitchFamily="34" charset="0"/>
+                <a:ea typeface="Calibri" pitchFamily="34" charset="-122"/>
+                <a:cs typeface="Calibri" pitchFamily="34" charset="-120"/>
+              </a:rPr>
+              <a:t>U + Be in-flight fission, separated and identified by BigRIPS:</a:t>
             </a:r>
             <a:endParaRPr lang="en-US" sz="1200" dirty="0"/>
           </a:p>
@@ -9797,7 +10016,7 @@
           <a:ln/>
         </p:spPr>
         <p:txBody>
-          <a:bodyPr wrap="square" lIns="0" tIns="0" rIns="0" bIns="0" rtlCol="0" anchor="ctr"/>
+          <a:bodyPr wrap="square" lIns="0" tIns="0" rIns="0" bIns="0" rtlCol="0" anchor="t"/>
           <a:lstStyle/>
           <a:p>
             <a:pPr indent="0" marL="0">
@@ -9824,7 +10043,7 @@
               <a:buNone/>
             </a:pPr>
             <a:r>
-              <a:rPr lang="en-US" sz="1200" b="1" dirty="0">
+              <a:rPr lang="en-US" sz="1200" b="1" baseline="30000" dirty="0">
                 <a:solidFill>
                   <a:srgbClr val="1E293B"/>
                 </a:solidFill>
@@ -9832,7 +10051,7 @@
                 <a:ea typeface="Calibri" pitchFamily="34" charset="-122"/>
                 <a:cs typeface="Calibri" pitchFamily="34" charset="-120"/>
               </a:rPr>
-              <a:t>78Ni region</a:t>
+              <a:t>78</a:t>
             </a:r>
             <a:pPr indent="0" marL="0">
               <a:spcAft>
@@ -9841,7 +10060,7 @@
               <a:buNone/>
             </a:pPr>
             <a:r>
-              <a:rPr lang="en-US" sz="1200" dirty="0">
+              <a:rPr lang="en-US" sz="1200" b="1" dirty="0">
                 <a:solidFill>
                   <a:srgbClr val="1E293B"/>
                 </a:solidFill>
@@ -9849,11 +10068,8 @@
                 <a:ea typeface="Calibri" pitchFamily="34" charset="-122"/>
                 <a:cs typeface="Calibri" pitchFamily="34" charset="-120"/>
               </a:rPr>
-              <a:t>: evolution of the N = 50 shell gap far from stability.</a:t>
-            </a:r>
-            <a:endParaRPr lang="en-US" sz="1200" dirty="0"/>
-          </a:p>
-          <a:p>
+              <a:t>Ni region</a:t>
+            </a:r>
             <a:pPr indent="0" marL="0">
               <a:spcAft>
                 <a:spcPts val="400"/>
@@ -9869,7 +10085,7 @@
                 <a:ea typeface="Calibri" pitchFamily="34" charset="-122"/>
                 <a:cs typeface="Calibri" pitchFamily="34" charset="-120"/>
               </a:rPr>
-              <a:t> </a:t>
+              <a:t>: evolution of the N = 50 shell gap far from stability.</a:t>
             </a:r>
             <a:endParaRPr lang="en-US" sz="1200" dirty="0"/>
           </a:p>
@@ -9889,7 +10105,61 @@
                 <a:ea typeface="Calibri" pitchFamily="34" charset="-122"/>
                 <a:cs typeface="Calibri" pitchFamily="34" charset="-120"/>
               </a:rPr>
-              <a:t>In-flight fission of 345 MeV/u 238U produces the short-lived Z ≈ 26–32 isotones in sufficient yield for cross-section and spectroscopy measurements.</a:t>
+              <a:t> </a:t>
+            </a:r>
+            <a:endParaRPr lang="en-US" sz="1200" dirty="0"/>
+          </a:p>
+          <a:p>
+            <a:pPr indent="0" marL="0">
+              <a:spcAft>
+                <a:spcPts val="400"/>
+              </a:spcAft>
+              <a:buNone/>
+            </a:pPr>
+            <a:r>
+              <a:rPr lang="en-US" sz="1200" dirty="0">
+                <a:solidFill>
+                  <a:srgbClr val="1E293B"/>
+                </a:solidFill>
+                <a:latin typeface="Calibri" pitchFamily="34" charset="0"/>
+                <a:ea typeface="Calibri" pitchFamily="34" charset="-122"/>
+                <a:cs typeface="Calibri" pitchFamily="34" charset="-120"/>
+              </a:rPr>
+              <a:t>In-flight fission of 345 MeV/u </a:t>
+            </a:r>
+            <a:pPr indent="0" marL="0">
+              <a:spcAft>
+                <a:spcPts val="400"/>
+              </a:spcAft>
+              <a:buNone/>
+            </a:pPr>
+            <a:r>
+              <a:rPr lang="en-US" sz="1200" baseline="30000" dirty="0">
+                <a:solidFill>
+                  <a:srgbClr val="1E293B"/>
+                </a:solidFill>
+                <a:latin typeface="Calibri" pitchFamily="34" charset="0"/>
+                <a:ea typeface="Calibri" pitchFamily="34" charset="-122"/>
+                <a:cs typeface="Calibri" pitchFamily="34" charset="-120"/>
+              </a:rPr>
+              <a:t>238</a:t>
+            </a:r>
+            <a:pPr indent="0" marL="0">
+              <a:spcAft>
+                <a:spcPts val="400"/>
+              </a:spcAft>
+              <a:buNone/>
+            </a:pPr>
+            <a:r>
+              <a:rPr lang="en-US" sz="1200" dirty="0">
+                <a:solidFill>
+                  <a:srgbClr val="1E293B"/>
+                </a:solidFill>
+                <a:latin typeface="Calibri" pitchFamily="34" charset="0"/>
+                <a:ea typeface="Calibri" pitchFamily="34" charset="-122"/>
+                <a:cs typeface="Calibri" pitchFamily="34" charset="-120"/>
+              </a:rPr>
+              <a:t>U produces the short-lived Z ≈ 26–32 isotones in sufficient yield for cross-section and spectroscopy measurements.</a:t>
             </a:r>
             <a:endParaRPr lang="en-US" sz="1200" dirty="0"/>
           </a:p>
@@ -10324,7 +10594,7 @@
           <a:ln/>
         </p:spPr>
         <p:txBody>
-          <a:bodyPr wrap="square" lIns="0" tIns="0" rIns="0" bIns="0" rtlCol="0" anchor="ctr"/>
+          <a:bodyPr wrap="square" lIns="0" tIns="0" rIns="0" bIns="0" rtlCol="0" anchor="t"/>
           <a:lstStyle/>
           <a:p>
             <a:pPr indent="0" marL="0">
@@ -10525,7 +10795,7 @@
           <a:ln/>
         </p:spPr>
         <p:txBody>
-          <a:bodyPr wrap="square" lIns="0" tIns="0" rIns="0" bIns="0" rtlCol="0" anchor="ctr"/>
+          <a:bodyPr wrap="square" lIns="0" tIns="0" rIns="0" bIns="0" rtlCol="0" anchor="t"/>
           <a:lstStyle/>
           <a:p>
             <a:pPr indent="0" marL="0">
@@ -10726,7 +10996,7 @@
           <a:ln/>
         </p:spPr>
         <p:txBody>
-          <a:bodyPr wrap="square" lIns="0" tIns="0" rIns="0" bIns="0" rtlCol="0" anchor="ctr"/>
+          <a:bodyPr wrap="square" lIns="0" tIns="0" rIns="0" bIns="0" rtlCol="0" anchor="t"/>
           <a:lstStyle/>
           <a:p>
             <a:pPr indent="0" marL="0">
@@ -11209,7 +11479,7 @@
           <a:ln/>
         </p:spPr>
         <p:txBody>
-          <a:bodyPr wrap="square" lIns="0" tIns="0" rIns="0" bIns="0" rtlCol="0" anchor="ctr"/>
+          <a:bodyPr wrap="square" lIns="0" tIns="0" rIns="0" bIns="0" rtlCol="0" anchor="t"/>
           <a:lstStyle/>
           <a:p>
             <a:pPr marL="342900" indent="-342900">
@@ -11228,7 +11498,41 @@
                 <a:ea typeface="Calibri" pitchFamily="34" charset="-122"/>
                 <a:cs typeface="Calibri" pitchFamily="34" charset="-120"/>
               </a:rPr>
-              <a:t>In-flight fission of 238U is the dominant route to mid-mass neutron-rich exotica.</a:t>
+              <a:t>In-flight fission of </a:t>
+            </a:r>
+            <a:pPr indent="0" marL="0">
+              <a:spcAft>
+                <a:spcPts val="600"/>
+              </a:spcAft>
+              <a:buNone/>
+            </a:pPr>
+            <a:r>
+              <a:rPr lang="en-US" sz="1400" baseline="30000" dirty="0">
+                <a:solidFill>
+                  <a:srgbClr val="F8FAFC"/>
+                </a:solidFill>
+                <a:latin typeface="Calibri" pitchFamily="34" charset="0"/>
+                <a:ea typeface="Calibri" pitchFamily="34" charset="-122"/>
+                <a:cs typeface="Calibri" pitchFamily="34" charset="-120"/>
+              </a:rPr>
+              <a:t>238</a:t>
+            </a:r>
+            <a:pPr indent="0" marL="0">
+              <a:spcAft>
+                <a:spcPts val="600"/>
+              </a:spcAft>
+              <a:buNone/>
+            </a:pPr>
+            <a:r>
+              <a:rPr lang="en-US" sz="1400" dirty="0">
+                <a:solidFill>
+                  <a:srgbClr val="F8FAFC"/>
+                </a:solidFill>
+                <a:latin typeface="Calibri" pitchFamily="34" charset="0"/>
+                <a:ea typeface="Calibri" pitchFamily="34" charset="-122"/>
+                <a:cs typeface="Calibri" pitchFamily="34" charset="-120"/>
+              </a:rPr>
+              <a:t>U is the dominant route to mid-mass neutron-rich exotica.</a:t>
             </a:r>
             <a:endParaRPr lang="en-US" sz="1400" dirty="0"/>
           </a:p>
@@ -11379,7 +11683,7 @@
           <a:ln/>
         </p:spPr>
         <p:txBody>
-          <a:bodyPr wrap="square" lIns="0" tIns="0" rIns="0" bIns="0" rtlCol="0" anchor="ctr"/>
+          <a:bodyPr wrap="square" lIns="0" tIns="0" rIns="0" bIns="0" rtlCol="0" anchor="t"/>
           <a:lstStyle/>
           <a:p>
             <a:pPr marL="342900" indent="-342900">

</xml_diff>